<commit_message>
study01: preserve author sketch of parallel sample and MDM pathways
</commit_message>
<xml_diff>
--- a/Study/Study 01 New/图片/F02_AMDM估计器流程-v8.pptx
+++ b/Study/Study 01 New/图片/F02_AMDM估计器流程-v8.pptx
@@ -812,6 +812,13 @@
             <a:prstDash val="dash"/>
           </a:ln>
         </p:spPr>
+        <p:txBody>
+          <a:bodyPr/>
+          <a:lstStyle/>
+          <a:p>
+            <a:endParaRPr lang="zh-CN" altLang="en-US"/>
+          </a:p>
+        </p:txBody>
       </p:sp>
       <p:sp>
         <p:nvSpPr>
@@ -830,7 +837,7 @@
         <p:spPr>
           <a:xfrm>
             <a:off x="285750" y="1428750"/>
-            <a:ext cx="3143250" cy="400050"/>
+            <a:ext cx="425130" cy="5710474"/>
           </a:xfrm>
           <a:prstGeom prst="rect">
             <a:avLst/>
@@ -843,6 +850,13 @@
             <a:prstDash val="solid"/>
           </a:ln>
         </p:spPr>
+        <p:txBody>
+          <a:bodyPr/>
+          <a:lstStyle/>
+          <a:p>
+            <a:endParaRPr lang="zh-CN" altLang="en-US"/>
+          </a:p>
+        </p:txBody>
       </p:sp>
       <p:sp>
         <p:nvSpPr>
@@ -860,7 +874,7 @@
         </p:nvSpPr>
         <p:spPr>
           <a:xfrm>
-            <a:off x="381000" y="1447800"/>
+            <a:off x="-1009271" y="4114799"/>
             <a:ext cx="2952750" cy="361950"/>
           </a:xfrm>
           <a:prstGeom prst="rect">
@@ -873,7 +887,7 @@
           </a:ln>
         </p:spPr>
         <p:txBody>
-          <a:bodyPr wrap="none" lIns="0" tIns="0" rIns="0" bIns="0" anchor="ctr">
+          <a:bodyPr vert="eaVert" wrap="none" lIns="0" tIns="0" rIns="0" bIns="0" anchor="ctr">
             <a:noAutofit/>
           </a:bodyPr>
           <a:lstStyle/>
@@ -889,7 +903,7 @@
               </a:defRPr>
             </a:pPr>
             <a:r>
-              <a:rPr sz="1800" b="1">
+              <a:rPr sz="1800" b="1" dirty="0" err="1">
                 <a:solidFill>
                   <a:srgbClr val="263238"/>
                 </a:solidFill>
@@ -899,6 +913,14 @@
               </a:rPr>
               <a:t>当前寿命样本</a:t>
             </a:r>
+            <a:endParaRPr sz="1800" b="1" dirty="0">
+              <a:solidFill>
+                <a:srgbClr val="263238"/>
+              </a:solidFill>
+              <a:latin typeface="Microsoft YaHei"/>
+              <a:ea typeface="Microsoft YaHei"/>
+              <a:cs typeface="Microsoft YaHei"/>
+            </a:endParaRPr>
           </a:p>
         </p:txBody>
       </p:sp>
@@ -946,6 +968,13 @@
             <a:prstDash val="solid"/>
           </a:ln>
         </p:spPr>
+        <p:txBody>
+          <a:bodyPr/>
+          <a:lstStyle/>
+          <a:p>
+            <a:endParaRPr lang="zh-CN" altLang="en-US"/>
+          </a:p>
+        </p:txBody>
       </p:sp>
       <p:sp>
         <p:nvSpPr>
@@ -991,6 +1020,13 @@
             <a:prstDash val="solid"/>
           </a:ln>
         </p:spPr>
+        <p:txBody>
+          <a:bodyPr/>
+          <a:lstStyle/>
+          <a:p>
+            <a:endParaRPr lang="zh-CN" altLang="en-US"/>
+          </a:p>
+        </p:txBody>
       </p:sp>
       <p:sp>
         <p:nvSpPr>
@@ -1023,6 +1059,13 @@
             </a:solidFill>
           </a:ln>
         </p:spPr>
+        <p:txBody>
+          <a:bodyPr/>
+          <a:lstStyle/>
+          <a:p>
+            <a:endParaRPr lang="zh-CN" altLang="en-US"/>
+          </a:p>
+        </p:txBody>
       </p:sp>
       <p:sp>
         <p:nvSpPr>
@@ -1068,6 +1111,13 @@
             <a:prstDash val="solid"/>
           </a:ln>
         </p:spPr>
+        <p:txBody>
+          <a:bodyPr/>
+          <a:lstStyle/>
+          <a:p>
+            <a:endParaRPr lang="zh-CN" altLang="en-US"/>
+          </a:p>
+        </p:txBody>
       </p:sp>
       <p:sp>
         <p:nvSpPr>
@@ -1100,6 +1150,13 @@
             </a:solidFill>
           </a:ln>
         </p:spPr>
+        <p:txBody>
+          <a:bodyPr/>
+          <a:lstStyle/>
+          <a:p>
+            <a:endParaRPr lang="zh-CN" altLang="en-US"/>
+          </a:p>
+        </p:txBody>
       </p:sp>
       <p:sp>
         <p:nvSpPr>
@@ -1145,6 +1202,13 @@
             <a:prstDash val="solid"/>
           </a:ln>
         </p:spPr>
+        <p:txBody>
+          <a:bodyPr/>
+          <a:lstStyle/>
+          <a:p>
+            <a:endParaRPr lang="zh-CN" altLang="en-US"/>
+          </a:p>
+        </p:txBody>
       </p:sp>
       <p:sp>
         <p:nvSpPr>
@@ -1177,6 +1241,13 @@
             </a:solidFill>
           </a:ln>
         </p:spPr>
+        <p:txBody>
+          <a:bodyPr/>
+          <a:lstStyle/>
+          <a:p>
+            <a:endParaRPr lang="zh-CN" altLang="en-US"/>
+          </a:p>
+        </p:txBody>
       </p:sp>
       <p:sp>
         <p:nvSpPr>
@@ -1222,6 +1293,13 @@
             <a:prstDash val="solid"/>
           </a:ln>
         </p:spPr>
+        <p:txBody>
+          <a:bodyPr/>
+          <a:lstStyle/>
+          <a:p>
+            <a:endParaRPr lang="zh-CN" altLang="en-US"/>
+          </a:p>
+        </p:txBody>
       </p:sp>
       <p:sp>
         <p:nvSpPr>
@@ -1254,6 +1332,13 @@
             </a:solidFill>
           </a:ln>
         </p:spPr>
+        <p:txBody>
+          <a:bodyPr/>
+          <a:lstStyle/>
+          <a:p>
+            <a:endParaRPr lang="zh-CN" altLang="en-US"/>
+          </a:p>
+        </p:txBody>
       </p:sp>
       <p:sp>
         <p:nvSpPr>
@@ -1299,6 +1384,13 @@
             <a:prstDash val="solid"/>
           </a:ln>
         </p:spPr>
+        <p:txBody>
+          <a:bodyPr/>
+          <a:lstStyle/>
+          <a:p>
+            <a:endParaRPr lang="zh-CN" altLang="en-US"/>
+          </a:p>
+        </p:txBody>
       </p:sp>
       <p:sp>
         <p:nvSpPr>
@@ -1331,6 +1423,13 @@
             </a:solidFill>
           </a:ln>
         </p:spPr>
+        <p:txBody>
+          <a:bodyPr/>
+          <a:lstStyle/>
+          <a:p>
+            <a:endParaRPr lang="zh-CN" altLang="en-US"/>
+          </a:p>
+        </p:txBody>
       </p:sp>
       <p:sp>
         <p:nvSpPr>
@@ -1376,6 +1475,13 @@
             <a:prstDash val="solid"/>
           </a:ln>
         </p:spPr>
+        <p:txBody>
+          <a:bodyPr/>
+          <a:lstStyle/>
+          <a:p>
+            <a:endParaRPr lang="zh-CN" altLang="en-US"/>
+          </a:p>
+        </p:txBody>
       </p:sp>
       <p:sp>
         <p:nvSpPr>
@@ -1408,6 +1514,13 @@
             </a:solidFill>
           </a:ln>
         </p:spPr>
+        <p:txBody>
+          <a:bodyPr/>
+          <a:lstStyle/>
+          <a:p>
+            <a:endParaRPr lang="zh-CN" altLang="en-US"/>
+          </a:p>
+        </p:txBody>
       </p:sp>
       <p:sp>
         <p:nvSpPr>
@@ -1453,6 +1566,13 @@
             <a:prstDash val="solid"/>
           </a:ln>
         </p:spPr>
+        <p:txBody>
+          <a:bodyPr/>
+          <a:lstStyle/>
+          <a:p>
+            <a:endParaRPr lang="zh-CN" altLang="en-US"/>
+          </a:p>
+        </p:txBody>
       </p:sp>
       <p:sp>
         <p:nvSpPr>
@@ -1485,6 +1605,13 @@
             </a:solidFill>
           </a:ln>
         </p:spPr>
+        <p:txBody>
+          <a:bodyPr/>
+          <a:lstStyle/>
+          <a:p>
+            <a:endParaRPr lang="zh-CN" altLang="en-US"/>
+          </a:p>
+        </p:txBody>
       </p:sp>
       <p:sp>
         <p:nvSpPr>
@@ -1546,10 +1673,10 @@
       </p:sp>
       <p:sp>
         <p:nvSpPr>
-          <p:cNvPr id="20" name="flow.sample-to-adapt">
-            <a:extLst>
-              <a:ext uri="{FF2B5EF4-FFF2-40B4-BE49-F238E27FC236}">
-                <a16:creationId xmlns:a16="http://schemas.microsoft.com/office/drawing/2014/main" id="{0FB3B9B3-7446-4F16-B520-FC490F9C51BB}"/>
+          <p:cNvPr id="21" name="adapt.boundary">
+            <a:extLst>
+              <a:ext uri="{FF2B5EF4-FFF2-40B4-BE49-F238E27FC236}">
+                <a16:creationId xmlns:a16="http://schemas.microsoft.com/office/drawing/2014/main" id="{25C05CD3-C167-4064-88B9-9B0269A3C370}"/>
               </a:ext>
             </a:extLst>
           </p:cNvPr>
@@ -1560,40 +1687,8 @@
         </p:nvSpPr>
         <p:spPr>
           <a:xfrm>
-            <a:off x="3619500" y="4191000"/>
-            <a:ext cx="400050" cy="190500"/>
-          </a:xfrm>
-          <a:prstGeom prst="rightArrow">
-            <a:avLst/>
-          </a:prstGeom>
-          <a:solidFill>
-            <a:srgbClr val="C6D9E7"/>
-          </a:solidFill>
-          <a:ln w="11430">
-            <a:solidFill>
-              <a:srgbClr val="73869A"/>
-            </a:solidFill>
-          </a:ln>
-        </p:spPr>
-      </p:sp>
-      <p:sp>
-        <p:nvSpPr>
-          <p:cNvPr id="21" name="adapt.boundary">
-            <a:extLst>
-              <a:ext uri="{FF2B5EF4-FFF2-40B4-BE49-F238E27FC236}">
-                <a16:creationId xmlns:a16="http://schemas.microsoft.com/office/drawing/2014/main" id="{25C05CD3-C167-4064-88B9-9B0269A3C370}"/>
-              </a:ext>
-            </a:extLst>
-          </p:cNvPr>
-          <p:cNvSpPr>
-            <a:spLocks noGrp="1"/>
-          </p:cNvSpPr>
-          <p:nvPr/>
-        </p:nvSpPr>
-        <p:spPr>
-          <a:xfrm>
-            <a:off x="4191000" y="1428750"/>
-            <a:ext cx="5429250" cy="5715000"/>
+            <a:off x="4381501" y="-1897141"/>
+            <a:ext cx="12191999" cy="2613181"/>
           </a:xfrm>
           <a:prstGeom prst="rect">
             <a:avLst/>
@@ -1606,6 +1701,13 @@
             <a:prstDash val="dash"/>
           </a:ln>
         </p:spPr>
+        <p:txBody>
+          <a:bodyPr/>
+          <a:lstStyle/>
+          <a:p>
+            <a:endParaRPr lang="zh-CN" altLang="en-US"/>
+          </a:p>
+        </p:txBody>
       </p:sp>
       <p:sp>
         <p:nvSpPr>
@@ -1623,8 +1725,8 @@
         </p:nvSpPr>
         <p:spPr>
           <a:xfrm>
-            <a:off x="4191000" y="1428750"/>
-            <a:ext cx="5429250" cy="400050"/>
+            <a:off x="4381502" y="-1897142"/>
+            <a:ext cx="458616" cy="2612228"/>
           </a:xfrm>
           <a:prstGeom prst="rect">
             <a:avLst/>
@@ -1637,6 +1739,13 @@
             <a:prstDash val="solid"/>
           </a:ln>
         </p:spPr>
+        <p:txBody>
+          <a:bodyPr/>
+          <a:lstStyle/>
+          <a:p>
+            <a:endParaRPr lang="zh-CN" altLang="en-US"/>
+          </a:p>
+        </p:txBody>
       </p:sp>
       <p:sp>
         <p:nvSpPr>
@@ -1654,7 +1763,7 @@
         </p:nvSpPr>
         <p:spPr>
           <a:xfrm>
-            <a:off x="4286250" y="1447800"/>
+            <a:off x="2713731" y="-1202610"/>
             <a:ext cx="5238750" cy="361950"/>
           </a:xfrm>
           <a:prstGeom prst="rect">
@@ -1683,7 +1792,7 @@
               </a:defRPr>
             </a:pPr>
             <a:r>
-              <a:rPr sz="1800" b="1">
+              <a:rPr sz="1800" b="1" dirty="0" err="1">
                 <a:solidFill>
                   <a:srgbClr val="263238"/>
                 </a:solidFill>
@@ -1693,6 +1802,14 @@
               </a:rPr>
               <a:t>样本自适应偏移选择</a:t>
             </a:r>
+            <a:endParaRPr sz="1800" b="1" dirty="0">
+              <a:solidFill>
+                <a:srgbClr val="263238"/>
+              </a:solidFill>
+              <a:latin typeface="Microsoft YaHei"/>
+              <a:ea typeface="Microsoft YaHei"/>
+              <a:cs typeface="Microsoft YaHei"/>
+            </a:endParaRPr>
           </a:p>
         </p:txBody>
       </p:sp>
@@ -1712,7 +1829,7 @@
         </p:nvSpPr>
         <p:spPr>
           <a:xfrm>
-            <a:off x="4476750" y="2114550"/>
+            <a:off x="4667252" y="-1211341"/>
             <a:ext cx="4857750" cy="342900"/>
           </a:xfrm>
           <a:prstGeom prst="rect">
@@ -1770,7 +1887,7 @@
         </p:nvSpPr>
         <p:spPr>
           <a:xfrm>
-            <a:off x="4476750" y="2543175"/>
+            <a:off x="4667252" y="-782716"/>
             <a:ext cx="4857750" cy="323850"/>
           </a:xfrm>
           <a:prstGeom prst="rect">
@@ -1827,8 +1944,8 @@
           <p:nvPr/>
         </p:nvSpPr>
         <p:spPr>
-          <a:xfrm>
-            <a:off x="6905625" y="3524250"/>
+          <a:xfrm rot="16200000">
+            <a:off x="8584400" y="-749855"/>
             <a:ext cx="953" cy="333375"/>
           </a:xfrm>
           <a:custGeom>
@@ -1856,6 +1973,13 @@
             <a:prstDash val="solid"/>
           </a:ln>
         </p:spPr>
+        <p:txBody>
+          <a:bodyPr/>
+          <a:lstStyle/>
+          <a:p>
+            <a:endParaRPr lang="zh-CN" altLang="en-US"/>
+          </a:p>
+        </p:txBody>
       </p:sp>
       <p:sp>
         <p:nvSpPr>
@@ -1872,8 +1996,8 @@
           <p:nvPr/>
         </p:nvSpPr>
         <p:spPr>
-          <a:xfrm>
-            <a:off x="6864195" y="3771857"/>
+          <a:xfrm rot="16200000">
+            <a:off x="8726327" y="-615096"/>
             <a:ext cx="82861" cy="85768"/>
           </a:xfrm>
           <a:custGeom>
@@ -1904,13 +2028,20 @@
             <a:prstDash val="solid"/>
           </a:ln>
         </p:spPr>
-      </p:sp>
-      <p:sp>
-        <p:nvSpPr>
-          <p:cNvPr id="28" name="adapt.standardize">
-            <a:extLst>
-              <a:ext uri="{FF2B5EF4-FFF2-40B4-BE49-F238E27FC236}">
-                <a16:creationId xmlns:a16="http://schemas.microsoft.com/office/drawing/2014/main" id="{A1856027-431F-49AB-9077-3DC9B5F389F1}"/>
+        <p:txBody>
+          <a:bodyPr/>
+          <a:lstStyle/>
+          <a:p>
+            <a:endParaRPr lang="zh-CN" altLang="en-US"/>
+          </a:p>
+        </p:txBody>
+      </p:sp>
+      <p:sp>
+        <p:nvSpPr>
+          <p:cNvPr id="29" name="adapt.model-box">
+            <a:extLst>
+              <a:ext uri="{FF2B5EF4-FFF2-40B4-BE49-F238E27FC236}">
+                <a16:creationId xmlns:a16="http://schemas.microsoft.com/office/drawing/2014/main" id="{A6B9F723-2894-449A-9E7A-D51AB17CEA81}"/>
               </a:ext>
             </a:extLst>
           </p:cNvPr>
@@ -1921,65 +2052,7 @@
         </p:nvSpPr>
         <p:spPr>
           <a:xfrm>
-            <a:off x="7172325" y="3495675"/>
-            <a:ext cx="1381125" cy="285750"/>
-          </a:xfrm>
-          <a:prstGeom prst="rect">
-            <a:avLst/>
-          </a:prstGeom>
-          <a:noFill/>
-          <a:ln w="12383">
-            <a:noFill/>
-            <a:prstDash val="solid"/>
-          </a:ln>
-        </p:spPr>
-        <p:txBody>
-          <a:bodyPr wrap="none" lIns="0" tIns="0" rIns="0" bIns="0" anchor="ctr">
-            <a:noAutofit/>
-          </a:bodyPr>
-          <a:lstStyle/>
-          <a:p>
-            <a:pPr algn="ctr">
-              <a:defRPr sz="1575" b="0">
-                <a:solidFill>
-                  <a:srgbClr val="82878C"/>
-                </a:solidFill>
-                <a:latin typeface="Microsoft YaHei"/>
-                <a:ea typeface="Microsoft YaHei"/>
-                <a:cs typeface="Microsoft YaHei"/>
-              </a:defRPr>
-            </a:pPr>
-            <a:r>
-              <a:rPr sz="1575" b="0">
-                <a:solidFill>
-                  <a:srgbClr val="82878C"/>
-                </a:solidFill>
-                <a:latin typeface="Microsoft YaHei"/>
-                <a:ea typeface="Microsoft YaHei"/>
-                <a:cs typeface="Microsoft YaHei"/>
-              </a:rPr>
-              <a:t>标准化</a:t>
-            </a:r>
-          </a:p>
-        </p:txBody>
-      </p:sp>
-      <p:sp>
-        <p:nvSpPr>
-          <p:cNvPr id="29" name="adapt.model-box">
-            <a:extLst>
-              <a:ext uri="{FF2B5EF4-FFF2-40B4-BE49-F238E27FC236}">
-                <a16:creationId xmlns:a16="http://schemas.microsoft.com/office/drawing/2014/main" id="{A6B9F723-2894-449A-9E7A-D51AB17CEA81}"/>
-              </a:ext>
-            </a:extLst>
-          </p:cNvPr>
-          <p:cNvSpPr>
-            <a:spLocks noGrp="1"/>
-          </p:cNvSpPr>
-          <p:nvPr/>
-        </p:nvSpPr>
-        <p:spPr>
-          <a:xfrm>
-            <a:off x="4810125" y="3981450"/>
+            <a:off x="9269259" y="-1225629"/>
             <a:ext cx="4191000" cy="1171575"/>
           </a:xfrm>
           <a:prstGeom prst="rect">
@@ -1995,6 +2068,13 @@
             <a:prstDash val="solid"/>
           </a:ln>
         </p:spPr>
+        <p:txBody>
+          <a:bodyPr/>
+          <a:lstStyle/>
+          <a:p>
+            <a:endParaRPr lang="zh-CN" altLang="en-US"/>
+          </a:p>
+        </p:txBody>
       </p:sp>
       <p:sp>
         <p:nvSpPr>
@@ -2012,7 +2092,7 @@
         </p:nvSpPr>
         <p:spPr>
           <a:xfrm>
-            <a:off x="4953000" y="4067175"/>
+            <a:off x="9412134" y="-1139904"/>
             <a:ext cx="3905250" cy="304800"/>
           </a:xfrm>
           <a:prstGeom prst="rect">
@@ -2070,7 +2150,7 @@
         </p:nvSpPr>
         <p:spPr>
           <a:xfrm>
-            <a:off x="4953000" y="4857750"/>
+            <a:off x="9412134" y="-349329"/>
             <a:ext cx="3905250" cy="266700"/>
           </a:xfrm>
           <a:prstGeom prst="rect">
@@ -2127,8 +2207,8 @@
           <p:nvPr/>
         </p:nvSpPr>
         <p:spPr>
-          <a:xfrm>
-            <a:off x="6905625" y="5267325"/>
+          <a:xfrm rot="16200000">
+            <a:off x="14085578" y="-726519"/>
             <a:ext cx="953" cy="285750"/>
           </a:xfrm>
           <a:custGeom>
@@ -2156,6 +2236,13 @@
             <a:prstDash val="solid"/>
           </a:ln>
         </p:spPr>
+        <p:txBody>
+          <a:bodyPr/>
+          <a:lstStyle/>
+          <a:p>
+            <a:endParaRPr lang="zh-CN" altLang="en-US"/>
+          </a:p>
+        </p:txBody>
       </p:sp>
       <p:sp>
         <p:nvSpPr>
@@ -2172,8 +2259,8 @@
           <p:nvPr/>
         </p:nvSpPr>
         <p:spPr>
-          <a:xfrm>
-            <a:off x="6864195" y="5467307"/>
+          <a:xfrm rot="16200000">
+            <a:off x="14221983" y="-583670"/>
             <a:ext cx="82861" cy="85768"/>
           </a:xfrm>
           <a:custGeom>
@@ -2204,6 +2291,13 @@
             <a:prstDash val="solid"/>
           </a:ln>
         </p:spPr>
+        <p:txBody>
+          <a:bodyPr/>
+          <a:lstStyle/>
+          <a:p>
+            <a:endParaRPr lang="zh-CN" altLang="en-US"/>
+          </a:p>
+        </p:txBody>
       </p:sp>
       <p:sp>
         <p:nvSpPr>
@@ -2221,7 +2315,7 @@
         </p:nvSpPr>
         <p:spPr>
           <a:xfrm>
-            <a:off x="4476750" y="5657850"/>
+            <a:off x="12839680" y="-125492"/>
             <a:ext cx="4857750" cy="333375"/>
           </a:xfrm>
           <a:prstGeom prst="rect">
@@ -2279,8 +2373,8 @@
         </p:nvSpPr>
         <p:spPr>
           <a:xfrm>
-            <a:off x="10572750" y="1428750"/>
-            <a:ext cx="6572250" cy="5715000"/>
+            <a:off x="4918146" y="1425652"/>
+            <a:ext cx="12191999" cy="5715000"/>
           </a:xfrm>
           <a:prstGeom prst="rect">
             <a:avLst/>
@@ -2293,6 +2387,13 @@
             <a:prstDash val="dash"/>
           </a:ln>
         </p:spPr>
+        <p:txBody>
+          <a:bodyPr/>
+          <a:lstStyle/>
+          <a:p>
+            <a:endParaRPr lang="zh-CN" altLang="en-US"/>
+          </a:p>
+        </p:txBody>
       </p:sp>
       <p:sp>
         <p:nvSpPr>
@@ -2310,8 +2411,8 @@
         </p:nvSpPr>
         <p:spPr>
           <a:xfrm>
-            <a:off x="10572750" y="1428750"/>
-            <a:ext cx="6572250" cy="400050"/>
+            <a:off x="4899853" y="1430176"/>
+            <a:ext cx="465107" cy="5710475"/>
           </a:xfrm>
           <a:prstGeom prst="rect">
             <a:avLst/>
@@ -2324,6 +2425,13 @@
             <a:prstDash val="solid"/>
           </a:ln>
         </p:spPr>
+        <p:txBody>
+          <a:bodyPr/>
+          <a:lstStyle/>
+          <a:p>
+            <a:endParaRPr lang="zh-CN" altLang="en-US"/>
+          </a:p>
+        </p:txBody>
       </p:sp>
       <p:sp>
         <p:nvSpPr>
@@ -2341,7 +2449,7 @@
         </p:nvSpPr>
         <p:spPr>
           <a:xfrm>
-            <a:off x="10668000" y="1447800"/>
+            <a:off x="1931714" y="4010819"/>
             <a:ext cx="6381750" cy="361950"/>
           </a:xfrm>
           <a:prstGeom prst="rect">
@@ -2354,7 +2462,7 @@
           </a:ln>
         </p:spPr>
         <p:txBody>
-          <a:bodyPr wrap="none" lIns="0" tIns="0" rIns="0" bIns="0" anchor="ctr">
+          <a:bodyPr vert="eaVert" wrap="none" lIns="0" tIns="0" rIns="0" bIns="0" anchor="ctr">
             <a:noAutofit/>
           </a:bodyPr>
           <a:lstStyle/>
@@ -2370,7 +2478,7 @@
               </a:defRPr>
             </a:pPr>
             <a:r>
-              <a:rPr sz="1800" b="1">
+              <a:rPr sz="1800" b="1" dirty="0" err="1">
                 <a:solidFill>
                   <a:srgbClr val="263238"/>
                 </a:solidFill>
@@ -2380,6 +2488,14 @@
               </a:rPr>
               <a:t>MDM参数求解</a:t>
             </a:r>
+            <a:endParaRPr sz="1800" b="1" dirty="0">
+              <a:solidFill>
+                <a:srgbClr val="263238"/>
+              </a:solidFill>
+              <a:latin typeface="Microsoft YaHei"/>
+              <a:ea typeface="Microsoft YaHei"/>
+              <a:cs typeface="Microsoft YaHei"/>
+            </a:endParaRPr>
           </a:p>
         </p:txBody>
       </p:sp>
@@ -2399,8 +2515,8 @@
         </p:nvSpPr>
         <p:spPr>
           <a:xfrm>
-            <a:off x="10953750" y="2333625"/>
-            <a:ext cx="5810250" cy="1219200"/>
+            <a:off x="6273719" y="3676650"/>
+            <a:ext cx="1919871" cy="1219200"/>
           </a:xfrm>
           <a:prstGeom prst="rect">
             <a:avLst/>
@@ -2415,6 +2531,13 @@
             <a:prstDash val="solid"/>
           </a:ln>
         </p:spPr>
+        <p:txBody>
+          <a:bodyPr/>
+          <a:lstStyle/>
+          <a:p>
+            <a:endParaRPr lang="zh-CN" altLang="en-US"/>
+          </a:p>
+        </p:txBody>
       </p:sp>
       <p:sp>
         <p:nvSpPr>
@@ -2432,7 +2555,7 @@
         </p:nvSpPr>
         <p:spPr>
           <a:xfrm>
-            <a:off x="11144250" y="2447925"/>
+            <a:off x="4510986" y="3882532"/>
             <a:ext cx="5429250" cy="323850"/>
           </a:xfrm>
           <a:prstGeom prst="rect">
@@ -2490,7 +2613,7 @@
         </p:nvSpPr>
         <p:spPr>
           <a:xfrm>
-            <a:off x="13858875" y="3667125"/>
+            <a:off x="10969230" y="3797139"/>
             <a:ext cx="953" cy="361950"/>
           </a:xfrm>
           <a:custGeom>
@@ -2518,6 +2641,13 @@
             <a:prstDash val="solid"/>
           </a:ln>
         </p:spPr>
+        <p:txBody>
+          <a:bodyPr/>
+          <a:lstStyle/>
+          <a:p>
+            <a:endParaRPr lang="zh-CN" altLang="en-US"/>
+          </a:p>
+        </p:txBody>
       </p:sp>
       <p:sp>
         <p:nvSpPr>
@@ -2535,7 +2665,7 @@
         </p:nvSpPr>
         <p:spPr>
           <a:xfrm>
-            <a:off x="13817445" y="3943307"/>
+            <a:off x="10927800" y="4073321"/>
             <a:ext cx="82861" cy="85768"/>
           </a:xfrm>
           <a:custGeom>
@@ -2566,6 +2696,13 @@
             <a:prstDash val="solid"/>
           </a:ln>
         </p:spPr>
+        <p:txBody>
+          <a:bodyPr/>
+          <a:lstStyle/>
+          <a:p>
+            <a:endParaRPr lang="zh-CN" altLang="en-US"/>
+          </a:p>
+        </p:txBody>
       </p:sp>
       <p:sp>
         <p:nvSpPr>
@@ -2583,7 +2720,7 @@
         </p:nvSpPr>
         <p:spPr>
           <a:xfrm>
-            <a:off x="11334750" y="4219575"/>
+            <a:off x="8445105" y="4349589"/>
             <a:ext cx="5048250" cy="333375"/>
           </a:xfrm>
           <a:prstGeom prst="rect">
@@ -2641,7 +2778,7 @@
         </p:nvSpPr>
         <p:spPr>
           <a:xfrm>
-            <a:off x="13858875" y="5334000"/>
+            <a:off x="10969230" y="5464014"/>
             <a:ext cx="953" cy="361950"/>
           </a:xfrm>
           <a:custGeom>
@@ -2669,6 +2806,13 @@
             <a:prstDash val="solid"/>
           </a:ln>
         </p:spPr>
+        <p:txBody>
+          <a:bodyPr/>
+          <a:lstStyle/>
+          <a:p>
+            <a:endParaRPr lang="zh-CN" altLang="en-US"/>
+          </a:p>
+        </p:txBody>
       </p:sp>
       <p:sp>
         <p:nvSpPr>
@@ -2686,7 +2830,7 @@
         </p:nvSpPr>
         <p:spPr>
           <a:xfrm>
-            <a:off x="13817445" y="5610182"/>
+            <a:off x="10927800" y="5740196"/>
             <a:ext cx="82861" cy="85768"/>
           </a:xfrm>
           <a:custGeom>
@@ -2717,6 +2861,13 @@
             <a:prstDash val="solid"/>
           </a:ln>
         </p:spPr>
+        <p:txBody>
+          <a:bodyPr/>
+          <a:lstStyle/>
+          <a:p>
+            <a:endParaRPr lang="zh-CN" altLang="en-US"/>
+          </a:p>
+        </p:txBody>
       </p:sp>
       <p:sp>
         <p:nvSpPr>
@@ -2734,7 +2885,7 @@
         </p:nvSpPr>
         <p:spPr>
           <a:xfrm>
-            <a:off x="11334750" y="5876925"/>
+            <a:off x="8445105" y="6006939"/>
             <a:ext cx="5048250" cy="333375"/>
           </a:xfrm>
           <a:prstGeom prst="rect">
@@ -2806,6 +2957,13 @@
             <a:prstDash val="dash"/>
           </a:ln>
         </p:spPr>
+        <p:txBody>
+          <a:bodyPr/>
+          <a:lstStyle/>
+          <a:p>
+            <a:endParaRPr lang="zh-CN" altLang="en-US"/>
+          </a:p>
+        </p:txBody>
       </p:sp>
       <p:sp>
         <p:nvSpPr>
@@ -2824,7 +2982,7 @@
         <p:spPr>
           <a:xfrm>
             <a:off x="18097500" y="1428750"/>
-            <a:ext cx="3905250" cy="400050"/>
+            <a:ext cx="501791" cy="5710474"/>
           </a:xfrm>
           <a:prstGeom prst="rect">
             <a:avLst/>
@@ -2837,6 +2995,13 @@
             <a:prstDash val="solid"/>
           </a:ln>
         </p:spPr>
+        <p:txBody>
+          <a:bodyPr/>
+          <a:lstStyle/>
+          <a:p>
+            <a:endParaRPr lang="zh-CN" altLang="en-US"/>
+          </a:p>
+        </p:txBody>
       </p:sp>
       <p:sp>
         <p:nvSpPr>
@@ -2854,7 +3019,7 @@
         </p:nvSpPr>
         <p:spPr>
           <a:xfrm>
-            <a:off x="18192750" y="1447800"/>
+            <a:off x="16573500" y="4114799"/>
             <a:ext cx="3714750" cy="361950"/>
           </a:xfrm>
           <a:prstGeom prst="rect">
@@ -2867,7 +3032,7 @@
           </a:ln>
         </p:spPr>
         <p:txBody>
-          <a:bodyPr wrap="none" lIns="0" tIns="0" rIns="0" bIns="0" anchor="ctr">
+          <a:bodyPr vert="eaVert" wrap="none" lIns="0" tIns="0" rIns="0" bIns="0" anchor="ctr">
             <a:noAutofit/>
           </a:bodyPr>
           <a:lstStyle/>
@@ -2883,7 +3048,7 @@
               </a:defRPr>
             </a:pPr>
             <a:r>
-              <a:rPr sz="1800" b="1">
+              <a:rPr sz="1800" b="1" dirty="0" err="1">
                 <a:solidFill>
                   <a:srgbClr val="263238"/>
                 </a:solidFill>
@@ -2893,373 +3058,16 @@
               </a:rPr>
               <a:t>AMDM估计结果</a:t>
             </a:r>
-          </a:p>
-        </p:txBody>
-      </p:sp>
-      <p:sp>
-        <p:nvSpPr>
-          <p:cNvPr id="49" name="flow.raw-sample">
-            <a:extLst>
-              <a:ext uri="{FF2B5EF4-FFF2-40B4-BE49-F238E27FC236}">
-                <a16:creationId xmlns:a16="http://schemas.microsoft.com/office/drawing/2014/main" id="{44E731F2-2F1A-4A82-8C9B-065BDD604D51}"/>
-              </a:ext>
-            </a:extLst>
-          </p:cNvPr>
-          <p:cNvSpPr>
-            <a:spLocks noGrp="1"/>
-          </p:cNvSpPr>
-          <p:nvPr/>
-        </p:nvSpPr>
-        <p:spPr>
-          <a:xfrm>
-            <a:off x="1857375" y="714375"/>
-            <a:ext cx="12001500" cy="714375"/>
-          </a:xfrm>
-          <a:custGeom>
-            <a:avLst/>
-            <a:gdLst/>
-            <a:ahLst/>
-            <a:cxnLst/>
-            <a:rect l="0" t="0" r="0" b="0"/>
-            <a:pathLst>
-              <a:path w="12001500" h="714375">
-                <a:moveTo>
-                  <a:pt x="0" y="714375"/>
-                </a:moveTo>
-                <a:lnTo>
-                  <a:pt x="0" y="0"/>
-                </a:lnTo>
-                <a:lnTo>
-                  <a:pt x="12001500" y="0"/>
-                </a:lnTo>
-                <a:lnTo>
-                  <a:pt x="12001500" y="714375"/>
-                </a:lnTo>
-              </a:path>
-            </a:pathLst>
-          </a:custGeom>
-          <a:noFill/>
-          <a:ln w="15240">
-            <a:solidFill>
-              <a:srgbClr val="82878C"/>
-            </a:solidFill>
-            <a:prstDash val="solid"/>
-          </a:ln>
-        </p:spPr>
-      </p:sp>
-      <p:sp>
-        <p:nvSpPr>
-          <p:cNvPr id="50" name="flow.raw-sample.head">
-            <a:extLst>
-              <a:ext uri="{FF2B5EF4-FFF2-40B4-BE49-F238E27FC236}">
-                <a16:creationId xmlns:a16="http://schemas.microsoft.com/office/drawing/2014/main" id="{DA3EDCBF-F7D1-41DB-B17E-C508C6C11A24}"/>
-              </a:ext>
-            </a:extLst>
-          </p:cNvPr>
-          <p:cNvSpPr>
-            <a:spLocks noGrp="1"/>
-          </p:cNvSpPr>
-          <p:nvPr/>
-        </p:nvSpPr>
-        <p:spPr>
-          <a:xfrm>
-            <a:off x="13817445" y="1342982"/>
-            <a:ext cx="82861" cy="85768"/>
-          </a:xfrm>
-          <a:custGeom>
-            <a:avLst/>
-            <a:gdLst/>
-            <a:ahLst/>
-            <a:cxnLst/>
-            <a:rect l="0" t="0" r="0" b="0"/>
-            <a:pathLst>
-              <a:path w="82861" h="85768">
-                <a:moveTo>
-                  <a:pt x="0" y="0"/>
-                </a:moveTo>
-                <a:lnTo>
-                  <a:pt x="41430" y="85768"/>
-                </a:lnTo>
-                <a:lnTo>
-                  <a:pt x="82861" y="0"/>
-                </a:lnTo>
-              </a:path>
-            </a:pathLst>
-          </a:custGeom>
-          <a:noFill/>
-          <a:ln w="15240">
-            <a:solidFill>
-              <a:srgbClr val="82878C"/>
-            </a:solidFill>
-            <a:prstDash val="solid"/>
-          </a:ln>
-        </p:spPr>
-      </p:sp>
-      <p:sp>
-        <p:nvSpPr>
-          <p:cNvPr id="51" name="flow.raw-label">
-            <a:extLst>
-              <a:ext uri="{FF2B5EF4-FFF2-40B4-BE49-F238E27FC236}">
-                <a16:creationId xmlns:a16="http://schemas.microsoft.com/office/drawing/2014/main" id="{A8D661F5-2B88-4EE6-A7C5-2C6F39925C05}"/>
-              </a:ext>
-            </a:extLst>
-          </p:cNvPr>
-          <p:cNvSpPr>
-            <a:spLocks noGrp="1"/>
-          </p:cNvSpPr>
-          <p:nvPr/>
-        </p:nvSpPr>
-        <p:spPr>
-          <a:xfrm>
-            <a:off x="5715000" y="266700"/>
-            <a:ext cx="4953000" cy="342900"/>
-          </a:xfrm>
-          <a:prstGeom prst="rect">
-            <a:avLst/>
-          </a:prstGeom>
-          <a:noFill/>
-          <a:ln w="12383">
-            <a:noFill/>
-            <a:prstDash val="solid"/>
-          </a:ln>
-        </p:spPr>
-        <p:txBody>
-          <a:bodyPr wrap="none" lIns="0" tIns="0" rIns="0" bIns="0" anchor="ctr">
-            <a:noAutofit/>
-          </a:bodyPr>
-          <a:lstStyle/>
-          <a:p>
-            <a:pPr algn="ctr">
-              <a:defRPr sz="1725" b="0">
-                <a:solidFill>
-                  <a:srgbClr val="82878C"/>
-                </a:solidFill>
-                <a:latin typeface="Microsoft YaHei"/>
-                <a:ea typeface="Microsoft YaHei"/>
-                <a:cs typeface="Microsoft YaHei"/>
-              </a:defRPr>
-            </a:pPr>
-            <a:r>
-              <a:rPr sz="1725" b="0">
-                <a:solidFill>
-                  <a:srgbClr val="82878C"/>
-                </a:solidFill>
-                <a:latin typeface="Microsoft YaHei"/>
-                <a:ea typeface="Microsoft YaHei"/>
-                <a:cs typeface="Microsoft YaHei"/>
-              </a:rPr>
-              <a:t>原始寿命样本进入MDM求解</a:t>
-            </a:r>
-          </a:p>
-        </p:txBody>
-      </p:sp>
-      <p:sp>
-        <p:nvSpPr>
-          <p:cNvPr id="52" name="flow.adaptive-offset">
-            <a:extLst>
-              <a:ext uri="{FF2B5EF4-FFF2-40B4-BE49-F238E27FC236}">
-                <a16:creationId xmlns:a16="http://schemas.microsoft.com/office/drawing/2014/main" id="{EF99F163-993E-436A-99A4-2FB25D0CC307}"/>
-              </a:ext>
-            </a:extLst>
-          </p:cNvPr>
-          <p:cNvSpPr>
-            <a:spLocks noGrp="1"/>
-          </p:cNvSpPr>
-          <p:nvPr/>
-        </p:nvSpPr>
-        <p:spPr>
-          <a:xfrm>
-            <a:off x="9620250" y="2952750"/>
-            <a:ext cx="1333500" cy="3524250"/>
-          </a:xfrm>
-          <a:custGeom>
-            <a:avLst/>
-            <a:gdLst/>
-            <a:ahLst/>
-            <a:cxnLst/>
-            <a:rect l="0" t="0" r="0" b="0"/>
-            <a:pathLst>
-              <a:path w="1333500" h="3524250">
-                <a:moveTo>
-                  <a:pt x="0" y="3524250"/>
-                </a:moveTo>
-                <a:lnTo>
-                  <a:pt x="476250" y="3524250"/>
-                </a:lnTo>
-                <a:lnTo>
-                  <a:pt x="476250" y="0"/>
-                </a:lnTo>
-                <a:lnTo>
-                  <a:pt x="1333500" y="0"/>
-                </a:lnTo>
-              </a:path>
-            </a:pathLst>
-          </a:custGeom>
-          <a:noFill/>
-          <a:ln w="15240">
-            <a:solidFill>
-              <a:srgbClr val="147AAA"/>
-            </a:solidFill>
-            <a:prstDash val="solid"/>
-          </a:ln>
-        </p:spPr>
-      </p:sp>
-      <p:sp>
-        <p:nvSpPr>
-          <p:cNvPr id="53" name="flow.adaptive-offset.head">
-            <a:extLst>
-              <a:ext uri="{FF2B5EF4-FFF2-40B4-BE49-F238E27FC236}">
-                <a16:creationId xmlns:a16="http://schemas.microsoft.com/office/drawing/2014/main" id="{DACE3533-13BA-480C-B2BE-C445D56D6B26}"/>
-              </a:ext>
-            </a:extLst>
-          </p:cNvPr>
-          <p:cNvSpPr>
-            <a:spLocks noGrp="1"/>
-          </p:cNvSpPr>
-          <p:nvPr/>
-        </p:nvSpPr>
-        <p:spPr>
-          <a:xfrm>
-            <a:off x="10867982" y="2911320"/>
-            <a:ext cx="85768" cy="82861"/>
-          </a:xfrm>
-          <a:custGeom>
-            <a:avLst/>
-            <a:gdLst/>
-            <a:ahLst/>
-            <a:cxnLst/>
-            <a:rect l="0" t="0" r="0" b="0"/>
-            <a:pathLst>
-              <a:path w="85768" h="82861">
-                <a:moveTo>
-                  <a:pt x="0" y="82861"/>
-                </a:moveTo>
-                <a:lnTo>
-                  <a:pt x="85768" y="41430"/>
-                </a:lnTo>
-                <a:lnTo>
-                  <a:pt x="0" y="0"/>
-                </a:lnTo>
-              </a:path>
-            </a:pathLst>
-          </a:custGeom>
-          <a:noFill/>
-          <a:ln w="15240">
-            <a:solidFill>
-              <a:srgbClr val="147AAA"/>
-            </a:solidFill>
-            <a:prstDash val="solid"/>
-          </a:ln>
-        </p:spPr>
-      </p:sp>
-      <p:sp>
-        <p:nvSpPr>
-          <p:cNvPr id="54" name="flow.offset-label">
-            <a:extLst>
-              <a:ext uri="{FF2B5EF4-FFF2-40B4-BE49-F238E27FC236}">
-                <a16:creationId xmlns:a16="http://schemas.microsoft.com/office/drawing/2014/main" id="{B3DD7741-B1D1-4C94-820A-4192844B72C0}"/>
-              </a:ext>
-            </a:extLst>
-          </p:cNvPr>
-          <p:cNvSpPr>
-            <a:spLocks noGrp="1"/>
-          </p:cNvSpPr>
-          <p:nvPr/>
-        </p:nvSpPr>
-        <p:spPr>
-          <a:xfrm>
-            <a:off x="9763125" y="2000250"/>
-            <a:ext cx="1524000" cy="285750"/>
-          </a:xfrm>
-          <a:prstGeom prst="rect">
-            <a:avLst/>
-          </a:prstGeom>
-          <a:noFill/>
-          <a:ln w="12383">
-            <a:noFill/>
-            <a:prstDash val="solid"/>
-          </a:ln>
-        </p:spPr>
-        <p:txBody>
-          <a:bodyPr wrap="none" lIns="0" tIns="0" rIns="0" bIns="0" anchor="ctr">
-            <a:noAutofit/>
-          </a:bodyPr>
-          <a:lstStyle/>
-          <a:p>
-            <a:pPr algn="ctr">
-              <a:defRPr sz="1575" b="0">
-                <a:solidFill>
-                  <a:srgbClr val="147AAA"/>
-                </a:solidFill>
-                <a:latin typeface="Microsoft YaHei"/>
-                <a:ea typeface="Microsoft YaHei"/>
-                <a:cs typeface="Microsoft YaHei"/>
-              </a:defRPr>
-            </a:pPr>
-            <a:r>
-              <a:rPr sz="1575" b="0">
-                <a:solidFill>
-                  <a:srgbClr val="147AAA"/>
-                </a:solidFill>
-                <a:latin typeface="Microsoft YaHei"/>
-                <a:ea typeface="Microsoft YaHei"/>
-                <a:cs typeface="Microsoft YaHei"/>
-              </a:rPr>
-              <a:t>自适应偏移</a:t>
-            </a:r>
-          </a:p>
-        </p:txBody>
-      </p:sp>
-      <p:sp>
-        <p:nvSpPr>
-          <p:cNvPr id="55" name="flow.result">
-            <a:extLst>
-              <a:ext uri="{FF2B5EF4-FFF2-40B4-BE49-F238E27FC236}">
-                <a16:creationId xmlns:a16="http://schemas.microsoft.com/office/drawing/2014/main" id="{A5EC811C-A1F5-4859-B283-039D2A404577}"/>
-              </a:ext>
-            </a:extLst>
-          </p:cNvPr>
-          <p:cNvSpPr>
-            <a:spLocks noGrp="1"/>
-          </p:cNvSpPr>
-          <p:nvPr/>
-        </p:nvSpPr>
-        <p:spPr>
-          <a:xfrm>
-            <a:off x="17145000" y="4286250"/>
-            <a:ext cx="952500" cy="2333625"/>
-          </a:xfrm>
-          <a:custGeom>
-            <a:avLst/>
-            <a:gdLst/>
-            <a:ahLst/>
-            <a:cxnLst/>
-            <a:rect l="0" t="0" r="0" b="0"/>
-            <a:pathLst>
-              <a:path w="952500" h="2333625">
-                <a:moveTo>
-                  <a:pt x="0" y="2333625"/>
-                </a:moveTo>
-                <a:lnTo>
-                  <a:pt x="447675" y="2333625"/>
-                </a:lnTo>
-                <a:lnTo>
-                  <a:pt x="447675" y="0"/>
-                </a:lnTo>
-                <a:lnTo>
-                  <a:pt x="952500" y="0"/>
-                </a:lnTo>
-              </a:path>
-            </a:pathLst>
-          </a:custGeom>
-          <a:noFill/>
-          <a:ln w="15240">
-            <a:solidFill>
-              <a:srgbClr val="82878C"/>
-            </a:solidFill>
-            <a:prstDash val="solid"/>
-          </a:ln>
-        </p:spPr>
+            <a:endParaRPr sz="1800" b="1" dirty="0">
+              <a:solidFill>
+                <a:srgbClr val="263238"/>
+              </a:solidFill>
+              <a:latin typeface="Microsoft YaHei"/>
+              <a:ea typeface="Microsoft YaHei"/>
+              <a:cs typeface="Microsoft YaHei"/>
+            </a:endParaRPr>
+          </a:p>
+        </p:txBody>
       </p:sp>
       <p:sp>
         <p:nvSpPr>
@@ -3308,6 +3116,13 @@
             <a:prstDash val="solid"/>
           </a:ln>
         </p:spPr>
+        <p:txBody>
+          <a:bodyPr/>
+          <a:lstStyle/>
+          <a:p>
+            <a:endParaRPr lang="zh-CN" altLang="en-US"/>
+          </a:p>
+        </p:txBody>
       </p:sp>
       <p:graphicFrame>
         <p:nvGraphicFramePr>
@@ -3387,13 +3202,13 @@
           <p:nvPr>
             <p:extLst>
               <p:ext uri="{D42A27DB-BD31-4B8C-83A1-F6EECF244321}">
-                <p14:modId xmlns:p14="http://schemas.microsoft.com/office/powerpoint/2010/main" val="310689310"/>
+                <p14:modId xmlns:p14="http://schemas.microsoft.com/office/powerpoint/2010/main" val="530033644"/>
               </p:ext>
             </p:extLst>
           </p:nvPr>
         </p:nvGraphicFramePr>
         <p:xfrm>
-          <a:off x="6318647" y="2959893"/>
+          <a:off x="6509149" y="-365998"/>
           <a:ext cx="1173956" cy="414339"/>
         </p:xfrm>
         <a:graphic>
@@ -3421,7 +3236,7 @@
                     </p:blipFill>
                     <p:spPr>
                       <a:xfrm>
-                        <a:off x="6318647" y="2959893"/>
+                        <a:off x="6509149" y="-365998"/>
                         <a:ext cx="1173956" cy="414339"/>
                       </a:xfrm>
                       <a:prstGeom prst="rect">
@@ -3450,13 +3265,13 @@
           <p:nvPr>
             <p:extLst>
               <p:ext uri="{D42A27DB-BD31-4B8C-83A1-F6EECF244321}">
-                <p14:modId xmlns:p14="http://schemas.microsoft.com/office/powerpoint/2010/main" val="149462958"/>
+                <p14:modId xmlns:p14="http://schemas.microsoft.com/office/powerpoint/2010/main" val="2580215744"/>
               </p:ext>
             </p:extLst>
           </p:nvPr>
         </p:nvGraphicFramePr>
         <p:xfrm>
-          <a:off x="6477002" y="4391025"/>
+          <a:off x="10936136" y="-816054"/>
           <a:ext cx="857247" cy="428625"/>
         </p:xfrm>
         <a:graphic>
@@ -3484,7 +3299,7 @@
                     </p:blipFill>
                     <p:spPr>
                       <a:xfrm>
-                        <a:off x="6477002" y="4391025"/>
+                        <a:off x="10936136" y="-816054"/>
                         <a:ext cx="857247" cy="428625"/>
                       </a:xfrm>
                       <a:prstGeom prst="rect">
@@ -3513,13 +3328,13 @@
           <p:nvPr>
             <p:extLst>
               <p:ext uri="{D42A27DB-BD31-4B8C-83A1-F6EECF244321}">
-                <p14:modId xmlns:p14="http://schemas.microsoft.com/office/powerpoint/2010/main" val="2486792782"/>
+                <p14:modId xmlns:p14="http://schemas.microsoft.com/office/powerpoint/2010/main" val="3178236679"/>
               </p:ext>
             </p:extLst>
           </p:nvPr>
         </p:nvGraphicFramePr>
         <p:xfrm>
-          <a:off x="6525817" y="6200775"/>
+          <a:off x="14602915" y="-820817"/>
           <a:ext cx="759616" cy="523875"/>
         </p:xfrm>
         <a:graphic>
@@ -3547,7 +3362,7 @@
                     </p:blipFill>
                     <p:spPr>
                       <a:xfrm>
-                        <a:off x="6525817" y="6200775"/>
+                        <a:off x="14602915" y="-820817"/>
                         <a:ext cx="759616" cy="523875"/>
                       </a:xfrm>
                       <a:prstGeom prst="rect">
@@ -3576,13 +3391,13 @@
           <p:nvPr>
             <p:extLst>
               <p:ext uri="{D42A27DB-BD31-4B8C-83A1-F6EECF244321}">
-                <p14:modId xmlns:p14="http://schemas.microsoft.com/office/powerpoint/2010/main" val="60477221"/>
+                <p14:modId xmlns:p14="http://schemas.microsoft.com/office/powerpoint/2010/main" val="3539802430"/>
               </p:ext>
             </p:extLst>
           </p:nvPr>
         </p:nvGraphicFramePr>
         <p:xfrm>
-          <a:off x="13727906" y="2939652"/>
+          <a:off x="10838261" y="3069666"/>
           <a:ext cx="261938" cy="445296"/>
         </p:xfrm>
         <a:graphic>
@@ -3610,7 +3425,7 @@
                     </p:blipFill>
                     <p:spPr>
                       <a:xfrm>
-                        <a:off x="13727906" y="2939652"/>
+                        <a:off x="10838261" y="3069666"/>
                         <a:ext cx="261938" cy="445296"/>
                       </a:xfrm>
                       <a:prstGeom prst="rect">
@@ -3639,13 +3454,13 @@
           <p:nvPr>
             <p:extLst>
               <p:ext uri="{D42A27DB-BD31-4B8C-83A1-F6EECF244321}">
-                <p14:modId xmlns:p14="http://schemas.microsoft.com/office/powerpoint/2010/main" val="3373538322"/>
+                <p14:modId xmlns:p14="http://schemas.microsoft.com/office/powerpoint/2010/main" val="440489032"/>
               </p:ext>
             </p:extLst>
           </p:nvPr>
         </p:nvGraphicFramePr>
         <p:xfrm>
-          <a:off x="13701713" y="4718446"/>
+          <a:off x="10812068" y="4848460"/>
           <a:ext cx="314325" cy="497683"/>
         </p:xfrm>
         <a:graphic>
@@ -3673,7 +3488,7 @@
                     </p:blipFill>
                     <p:spPr>
                       <a:xfrm>
-                        <a:off x="13701713" y="4718446"/>
+                        <a:off x="10812068" y="4848460"/>
                         <a:ext cx="314325" cy="497683"/>
                       </a:xfrm>
                       <a:prstGeom prst="rect">
@@ -3702,13 +3517,13 @@
           <p:nvPr>
             <p:extLst>
               <p:ext uri="{D42A27DB-BD31-4B8C-83A1-F6EECF244321}">
-                <p14:modId xmlns:p14="http://schemas.microsoft.com/office/powerpoint/2010/main" val="2487432513"/>
+                <p14:modId xmlns:p14="http://schemas.microsoft.com/office/powerpoint/2010/main" val="3806095705"/>
               </p:ext>
             </p:extLst>
           </p:nvPr>
         </p:nvGraphicFramePr>
         <p:xfrm>
-          <a:off x="13727906" y="6411514"/>
+          <a:off x="10838261" y="6541528"/>
           <a:ext cx="261938" cy="445296"/>
         </p:xfrm>
         <a:graphic>
@@ -3736,7 +3551,7 @@
                     </p:blipFill>
                     <p:spPr>
                       <a:xfrm>
-                        <a:off x="13727906" y="6411514"/>
+                        <a:off x="10838261" y="6541528"/>
                         <a:ext cx="261938" cy="445296"/>
                       </a:xfrm>
                       <a:prstGeom prst="rect">
@@ -3801,6 +3616,197 @@
                       <a:xfrm>
                         <a:off x="18772584" y="3975099"/>
                         <a:ext cx="2555081" cy="460377"/>
+                      </a:xfrm>
+                      <a:prstGeom prst="rect">
+                        <a:avLst/>
+                      </a:prstGeom>
+                    </p:spPr>
+                  </p:pic>
+                </p:oleObj>
+              </mc:Fallback>
+            </mc:AlternateContent>
+          </a:graphicData>
+        </a:graphic>
+      </p:graphicFrame>
+      <p:sp>
+        <p:nvSpPr>
+          <p:cNvPr id="67" name="flow.sample-to-adapt">
+            <a:extLst>
+              <a:ext uri="{FF2B5EF4-FFF2-40B4-BE49-F238E27FC236}">
+                <a16:creationId xmlns:a16="http://schemas.microsoft.com/office/drawing/2014/main" id="{ECBC6013-AD7B-3FFF-3D47-0D83C96B578E}"/>
+              </a:ext>
+            </a:extLst>
+          </p:cNvPr>
+          <p:cNvSpPr>
+            <a:spLocks noGrp="1"/>
+          </p:cNvSpPr>
+          <p:nvPr/>
+        </p:nvSpPr>
+        <p:spPr>
+          <a:xfrm>
+            <a:off x="16697706" y="3978071"/>
+            <a:ext cx="400050" cy="190500"/>
+          </a:xfrm>
+          <a:prstGeom prst="rightArrow">
+            <a:avLst/>
+          </a:prstGeom>
+          <a:solidFill>
+            <a:srgbClr val="C6D9E7"/>
+          </a:solidFill>
+          <a:ln w="11430">
+            <a:solidFill>
+              <a:srgbClr val="73869A"/>
+            </a:solidFill>
+          </a:ln>
+        </p:spPr>
+        <p:txBody>
+          <a:bodyPr/>
+          <a:lstStyle/>
+          <a:p>
+            <a:endParaRPr lang="zh-CN" altLang="en-US"/>
+          </a:p>
+        </p:txBody>
+      </p:sp>
+      <p:cxnSp>
+        <p:nvCxnSpPr>
+          <p:cNvPr id="69" name="连接符: 肘形 68">
+            <a:extLst>
+              <a:ext uri="{FF2B5EF4-FFF2-40B4-BE49-F238E27FC236}">
+                <a16:creationId xmlns:a16="http://schemas.microsoft.com/office/drawing/2014/main" id="{28AFB44D-56E1-18C7-9AED-B71EAA76B274}"/>
+              </a:ext>
+            </a:extLst>
+          </p:cNvPr>
+          <p:cNvCxnSpPr>
+            <a:cxnSpLocks/>
+            <a:stCxn id="57" idx="3"/>
+            <a:endCxn id="21" idx="1"/>
+          </p:cNvCxnSpPr>
+          <p:nvPr/>
+        </p:nvCxnSpPr>
+        <p:spPr>
+          <a:xfrm flipV="1">
+            <a:off x="3429000" y="-590550"/>
+            <a:ext cx="952501" cy="4876800"/>
+          </a:xfrm>
+          <a:prstGeom prst="bentConnector3">
+            <a:avLst/>
+          </a:prstGeom>
+          <a:ln>
+            <a:tailEnd type="triangle"/>
+          </a:ln>
+        </p:spPr>
+        <p:style>
+          <a:lnRef idx="1">
+            <a:schemeClr val="accent1"/>
+          </a:lnRef>
+          <a:fillRef idx="0">
+            <a:schemeClr val="accent1"/>
+          </a:fillRef>
+          <a:effectRef idx="0">
+            <a:schemeClr val="accent1"/>
+          </a:effectRef>
+          <a:fontRef idx="minor">
+            <a:schemeClr val="tx1"/>
+          </a:fontRef>
+        </p:style>
+      </p:cxnSp>
+      <p:cxnSp>
+        <p:nvCxnSpPr>
+          <p:cNvPr id="71" name="连接符: 肘形 70">
+            <a:extLst>
+              <a:ext uri="{FF2B5EF4-FFF2-40B4-BE49-F238E27FC236}">
+                <a16:creationId xmlns:a16="http://schemas.microsoft.com/office/drawing/2014/main" id="{295060D5-DDC0-D148-FD90-AE995CCDD580}"/>
+              </a:ext>
+            </a:extLst>
+          </p:cNvPr>
+          <p:cNvCxnSpPr>
+            <a:cxnSpLocks/>
+            <a:stCxn id="21" idx="3"/>
+            <a:endCxn id="38" idx="0"/>
+          </p:cNvCxnSpPr>
+          <p:nvPr/>
+        </p:nvCxnSpPr>
+        <p:spPr>
+          <a:xfrm flipH="1">
+            <a:off x="7233655" y="-590550"/>
+            <a:ext cx="9339845" cy="4267200"/>
+          </a:xfrm>
+          <a:prstGeom prst="bentConnector4">
+            <a:avLst>
+              <a:gd name="adj1" fmla="val -2448"/>
+              <a:gd name="adj2" fmla="val 65310"/>
+            </a:avLst>
+          </a:prstGeom>
+          <a:ln>
+            <a:tailEnd type="triangle"/>
+          </a:ln>
+        </p:spPr>
+        <p:style>
+          <a:lnRef idx="1">
+            <a:schemeClr val="accent1"/>
+          </a:lnRef>
+          <a:fillRef idx="0">
+            <a:schemeClr val="accent1"/>
+          </a:fillRef>
+          <a:effectRef idx="0">
+            <a:schemeClr val="accent1"/>
+          </a:effectRef>
+          <a:fontRef idx="minor">
+            <a:schemeClr val="tx1"/>
+          </a:fontRef>
+        </p:style>
+      </p:cxnSp>
+      <p:graphicFrame>
+        <p:nvGraphicFramePr>
+          <p:cNvPr id="77" name="对象 76">
+            <a:extLst>
+              <a:ext uri="{FF2B5EF4-FFF2-40B4-BE49-F238E27FC236}">
+                <a16:creationId xmlns:a16="http://schemas.microsoft.com/office/drawing/2014/main" id="{D3D66530-37B4-D21C-0B3C-6016D5751993}"/>
+              </a:ext>
+            </a:extLst>
+          </p:cNvPr>
+          <p:cNvGraphicFramePr>
+            <a:graphicFrameLocks noChangeAspect="1"/>
+          </p:cNvGraphicFramePr>
+          <p:nvPr>
+            <p:extLst>
+              <p:ext uri="{D42A27DB-BD31-4B8C-83A1-F6EECF244321}">
+                <p14:modId xmlns:p14="http://schemas.microsoft.com/office/powerpoint/2010/main" val="3503218865"/>
+              </p:ext>
+            </p:extLst>
+          </p:nvPr>
+        </p:nvGraphicFramePr>
+        <p:xfrm>
+          <a:off x="16938605" y="453148"/>
+          <a:ext cx="758825" cy="523875"/>
+        </p:xfrm>
+        <a:graphic>
+          <a:graphicData uri="http://schemas.openxmlformats.org/presentationml/2006/ole">
+            <mc:AlternateContent xmlns:mc="http://schemas.openxmlformats.org/markup-compatibility/2006">
+              <mc:Choice xmlns:v="urn:schemas-microsoft-com:vml" Requires="v">
+                <p:oleObj name="Equation" r:id="rId19" imgW="758937" imgH="524539" progId="Equation.DSMT4">
+                  <p:embed/>
+                </p:oleObj>
+              </mc:Choice>
+              <mc:Fallback>
+                <p:oleObj name="Equation" r:id="rId19" imgW="758937" imgH="524539" progId="Equation.DSMT4">
+                  <p:embed/>
+                  <p:pic>
+                    <p:nvPicPr>
+                      <p:cNvPr id="0" name=""/>
+                      <p:cNvPicPr/>
+                      <p:nvPr/>
+                    </p:nvPicPr>
+                    <p:blipFill>
+                      <a:blip r:embed="rId20"/>
+                      <a:stretch>
+                        <a:fillRect/>
+                      </a:stretch>
+                    </p:blipFill>
+                    <p:spPr>
+                      <a:xfrm>
+                        <a:off x="16938605" y="453148"/>
+                        <a:ext cx="758825" cy="523875"/>
                       </a:xfrm>
                       <a:prstGeom prst="rect">
                         <a:avLst/>

</xml_diff>